<commit_message>
Replace corporate master: template residue → placeholders
</commit_message>
<xml_diff>
--- a/backend/redesigner/masters/master_style_2_corporate.pptx
+++ b/backend/redesigner/masters/master_style_2_corporate.pptx
@@ -4071,7 +4071,7 @@
                 </a:solidFill>
                 <a:latin typeface="Lato"/>
               </a:rPr>
-              <a:t>ОБ ЭТОМ РАЗДЕЛЕ</a:t>
+              <a:t>{SECTION_LABEL}</a:t>
             </a:r>
           </a:p>
         </p:txBody>
@@ -5323,7 +5323,7 @@
                 </a:solidFill>
                 <a:latin typeface="Lato"/>
               </a:rPr>
-              <a:t>ЛЕВАЯ СТОРОНА</a:t>
+              <a:t>{LEFT_LABEL}</a:t>
             </a:r>
           </a:p>
         </p:txBody>
@@ -5507,7 +5507,7 @@
                 </a:solidFill>
                 <a:latin typeface="Lato"/>
               </a:rPr>
-              <a:t>ПРАВАЯ СТОРОНА</a:t>
+              <a:t>{RIGHT_LABEL}</a:t>
             </a:r>
           </a:p>
         </p:txBody>

</xml_diff>